<commit_message>
Add model.json analysis slides to train.kr.py.pptx
Append two appendix slides analyzing the model.json that train.py saves:
APPENDIX 1 shows its structure (config / chars / weights, 88 KB, generated at
L269-282) and APPENDIX 2 breaks down the 4,064 weight parameters across the 9
matrices with a native bar chart. Deck is now 14 slides; validated.

Co-Authored-By: Claude Opus 4.8 <noreply@anthropic.com>
Claude-Session: https://claude.ai/code/session_01RUKYWxeKny9e8cLfaQaaMn
</commit_message>
<xml_diff>
--- a/persistence/train.kr.py.pptx
+++ b/persistence/train.kr.py.pptx
@@ -17,9 +17,11 @@
     <p:sldId id="265" r:id="rId11"/>
     <p:sldId id="266" r:id="rId12"/>
     <p:sldId id="267" r:id="rId13"/>
+    <p:sldId id="268" r:id="rId14"/>
+    <p:sldId id="269" r:id="rId15"/>
   </p:sldIdLst>
   <p:notesMasterIdLst>
-    <p:notesMasterId r:id="rId14"/>
+    <p:notesMasterId r:id="rId16"/>
   </p:notesMasterIdLst>
   <p:sldSz cx="12192000" cy="6858000"/>
   <p:notesSz cx="6858000" cy="12192000"/>
@@ -116,6 +118,273 @@
     </a:lvl9pPr>
   </p:defaultTextStyle>
 </p:presentation>
+</file>
+
+<file path=ppt/charts/chart1.xml><?xml version="1.0" encoding="utf-8"?>
+<c:chartSpace xmlns:c="http://schemas.openxmlformats.org/drawingml/2006/chart" xmlns:a="http://schemas.openxmlformats.org/drawingml/2006/main" xmlns:r="http://schemas.openxmlformats.org/officeDocument/2006/relationships">
+  <c:date1904 val="0"/>
+  <c:roundedCorners val="1"/>
+  <c:chart>
+    <c:autoTitleDeleted val="1"/>
+    <c:plotArea>
+      <c:layout/>
+      <c:barChart>
+        <c:barDir val="bar"/>
+        <c:grouping val="clustered"/>
+        <c:varyColors val="0"/>
+        <c:ser>
+          <c:idx val="0"/>
+          <c:order val="0"/>
+          <c:tx>
+            <c:strRef>
+              <c:f>Sheet1!$B$1</c:f>
+              <c:strCache>
+                <c:ptCount val="1"/>
+                <c:pt idx="0">
+                  <c:v>파라미터 수</c:v>
+                </c:pt>
+              </c:strCache>
+            </c:strRef>
+          </c:tx>
+          <c:spPr>
+            <a:solidFill>
+              <a:srgbClr val="7EE787"/>
+            </a:solidFill>
+            <a:effectLst/>
+          </c:spPr>
+          <c:invertIfNegative val="0"/>
+          <c:dLbls>
+            <c:numFmt formatCode="#,##0" sourceLinked="0"/>
+            <c:txPr>
+              <a:bodyPr/>
+              <a:lstStyle/>
+              <a:p>
+                <a:pPr>
+                  <a:defRPr b="1" i="0" strike="noStrike" sz="1000" u="none">
+                    <a:solidFill>
+                      <a:srgbClr val="24292F"/>
+                    </a:solidFill>
+                    <a:latin typeface="Arial"/>
+                  </a:defRPr>
+                </a:pPr>
+              </a:p>
+            </c:txPr>
+            <c:showLegendKey val="0"/>
+            <c:showVal val="1"/>
+            <c:showCatName val="0"/>
+            <c:showSerName val="0"/>
+            <c:showPercent val="0"/>
+            <c:showBubbleSize val="0"/>
+            <c:showLeaderLines val="0"/>
+          </c:dLbls>
+          <c:cat>
+            <c:multiLvlStrRef>
+              <c:f>Sheet1!$A$2:$A$10</c:f>
+              <c:multiLvlStrCache>
+                <c:ptCount val="9"/>
+                <c:lvl>
+                  <c:pt idx="0">
+                    <c:v>mlp_fc1</c:v>
+                  </c:pt>
+                  <c:pt idx="1">
+                    <c:v>mlp_fc2</c:v>
+                  </c:pt>
+                  <c:pt idx="2">
+                    <c:v>wte</c:v>
+                  </c:pt>
+                  <c:pt idx="3">
+                    <c:v>lm_head</c:v>
+                  </c:pt>
+                  <c:pt idx="4">
+                    <c:v>attn_wq</c:v>
+                  </c:pt>
+                  <c:pt idx="5">
+                    <c:v>attn_wk</c:v>
+                  </c:pt>
+                  <c:pt idx="6">
+                    <c:v>attn_wv</c:v>
+                  </c:pt>
+                  <c:pt idx="7">
+                    <c:v>attn_wo</c:v>
+                  </c:pt>
+                  <c:pt idx="8">
+                    <c:v>wpe</c:v>
+                  </c:pt>
+                </c:lvl>
+              </c:multiLvlStrCache>
+            </c:multiLvlStrRef>
+          </c:cat>
+          <c:val>
+            <c:numRef>
+              <c:f>Sheet1!$B$2:$B$10</c:f>
+              <c:numCache>
+                <c:formatCode>General</c:formatCode>
+                <c:ptCount val="9"/>
+                <c:pt idx="0">
+                  <c:v>1024</c:v>
+                </c:pt>
+                <c:pt idx="1">
+                  <c:v>1024</c:v>
+                </c:pt>
+                <c:pt idx="2">
+                  <c:v>432</c:v>
+                </c:pt>
+                <c:pt idx="3">
+                  <c:v>432</c:v>
+                </c:pt>
+                <c:pt idx="4">
+                  <c:v>256</c:v>
+                </c:pt>
+                <c:pt idx="5">
+                  <c:v>256</c:v>
+                </c:pt>
+                <c:pt idx="6">
+                  <c:v>256</c:v>
+                </c:pt>
+                <c:pt idx="7">
+                  <c:v>256</c:v>
+                </c:pt>
+                <c:pt idx="8">
+                  <c:v>128</c:v>
+                </c:pt>
+              </c:numCache>
+            </c:numRef>
+          </c:val>
+        </c:ser>
+        <c:dLbls>
+          <c:numFmt formatCode="#,##0" sourceLinked="0"/>
+          <c:txPr>
+            <a:bodyPr/>
+            <a:lstStyle/>
+            <a:p>
+              <a:pPr>
+                <a:defRPr b="1" i="0" strike="noStrike" sz="1000" u="none">
+                  <a:solidFill>
+                    <a:srgbClr val="24292F"/>
+                  </a:solidFill>
+                  <a:latin typeface="Arial"/>
+                </a:defRPr>
+              </a:pPr>
+            </a:p>
+          </c:txPr>
+          <c:showLegendKey val="0"/>
+          <c:showVal val="1"/>
+          <c:showCatName val="0"/>
+          <c:showSerName val="0"/>
+          <c:showPercent val="0"/>
+          <c:showBubbleSize val="0"/>
+          <c:showLeaderLines val="0"/>
+        </c:dLbls>
+        <c:gapWidth val="150"/>
+        <c:overlap val="0"/>
+        <c:axId val="2094734554"/>
+        <c:axId val="2094734552"/>
+        <c:axId val="2094734556"/>
+      </c:barChart>
+      <c:catAx>
+        <c:axId val="2094734554"/>
+        <c:scaling>
+          <c:orientation val="minMax"/>
+        </c:scaling>
+        <c:delete val="0"/>
+        <c:axPos val="l"/>
+        <c:numFmt formatCode="General" sourceLinked="1"/>
+        <c:majorTickMark val="out"/>
+        <c:minorTickMark val="none"/>
+        <c:tickLblPos val="nextTo"/>
+        <c:spPr>
+          <a:ln w="12700" cap="flat">
+            <a:solidFill>
+              <a:srgbClr val="888888"/>
+            </a:solidFill>
+            <a:prstDash val="solid"/>
+            <a:round/>
+          </a:ln>
+        </c:spPr>
+        <c:txPr>
+          <a:bodyPr/>
+          <a:lstStyle/>
+          <a:p>
+            <a:pPr>
+              <a:defRPr sz="1000" b="0" i="0" u="none" strike="noStrike">
+                <a:solidFill>
+                  <a:srgbClr val="24292F"/>
+                </a:solidFill>
+                <a:latin typeface="Courier New"/>
+              </a:defRPr>
+            </a:pPr>
+            <a:endParaRPr lang="en-US"/>
+          </a:p>
+        </c:txPr>
+        <c:crossAx val="2094734552"/>
+        <c:crosses val="autoZero"/>
+        <c:auto val="1"/>
+        <c:lblAlgn val="ctr"/>
+        <c:noMultiLvlLbl val="1"/>
+      </c:catAx>
+      <c:valAx>
+        <c:axId val="2094734552"/>
+        <c:scaling>
+          <c:orientation val="minMax"/>
+          <c:max val="1200"/>
+          <c:min val="0"/>
+        </c:scaling>
+        <c:delete val="1"/>
+        <c:axPos val="b"/>
+        <c:numFmt formatCode="General" sourceLinked="0"/>
+        <c:majorTickMark val="out"/>
+        <c:minorTickMark val="none"/>
+        <c:tickLblPos val="low"/>
+        <c:spPr>
+          <a:ln w="12700" cap="flat">
+            <a:solidFill>
+              <a:srgbClr val="888888"/>
+            </a:solidFill>
+            <a:prstDash val="solid"/>
+            <a:round/>
+          </a:ln>
+        </c:spPr>
+        <c:txPr>
+          <a:bodyPr/>
+          <a:lstStyle/>
+          <a:p>
+            <a:pPr>
+              <a:defRPr sz="1200" b="0" i="0" u="none" strike="noStrike">
+                <a:solidFill>
+                  <a:srgbClr val="000000"/>
+                </a:solidFill>
+                <a:latin typeface="Arial"/>
+              </a:defRPr>
+            </a:pPr>
+            <a:endParaRPr lang="en-US"/>
+          </a:p>
+        </c:txPr>
+        <c:crossAx val="2094734554"/>
+        <c:crosses val="autoZero"/>
+        <c:crossBetween val="between"/>
+      </c:valAx>
+      <c:spPr>
+        <a:noFill/>
+        <a:ln>
+          <a:noFill/>
+        </a:ln>
+        <a:effectLst/>
+      </c:spPr>
+    </c:plotArea>
+    <c:plotVisOnly val="1"/>
+    <c:dispBlanksAs val="span"/>
+  </c:chart>
+  <c:spPr>
+    <a:noFill/>
+    <a:ln>
+      <a:noFill/>
+    </a:ln>
+    <a:effectLst/>
+  </c:spPr>
+  <c:externalData r:id="rId1">
+    <c:autoUpdate val="0"/>
+  </c:externalData>
+</c:chartSpace>
 </file>
 
 <file path=ppt/notesMasters/notesMaster1.xml><?xml version="1.0" encoding="utf-8"?>
@@ -801,6 +1070,182 @@
             <a:fld id="{F7021451-1387-4CA6-816F-3879F97B5CBC}" type="slidenum">
               <a:rPr lang="en-US"/>
               <a:t>12</a:t>
+            </a:fld>
+            <a:endParaRPr lang="en-US"/>
+          </a:p>
+        </p:txBody>
+      </p:sp>
+    </p:spTree>
+    <p:extLst>
+      <p:ext uri="{BB962C8B-B14F-4D97-AF65-F5344CB8AC3E}">
+        <p14:creationId xmlns:p14="http://schemas.microsoft.com/office/powerpoint/2010/main" val="1024086991"/>
+      </p:ext>
+    </p:extLst>
+  </p:cSld>
+  <p:clrMapOvr>
+    <a:masterClrMapping/>
+  </p:clrMapOvr>
+</p:notes>
+</file>
+
+<file path=ppt/notesSlides/notesSlide13.xml><?xml version="1.0" encoding="utf-8"?>
+<p:notes xmlns:a="http://schemas.openxmlformats.org/drawingml/2006/main" xmlns:r="http://schemas.openxmlformats.org/officeDocument/2006/relationships" xmlns:p="http://schemas.openxmlformats.org/presentationml/2006/main">
+  <p:cSld>
+    <p:spTree>
+      <p:nvGrpSpPr>
+        <p:cNvPr id="1" name=""/>
+        <p:cNvGrpSpPr/>
+        <p:nvPr/>
+      </p:nvGrpSpPr>
+      <p:grpSpPr>
+        <a:xfrm>
+          <a:off x="0" y="0"/>
+          <a:ext cx="0" cy="0"/>
+          <a:chOff x="0" y="0"/>
+          <a:chExt cx="0" cy="0"/>
+        </a:xfrm>
+      </p:grpSpPr>
+      <p:sp>
+        <p:nvSpPr>
+          <p:cNvPr id="2" name="Slide Image Placeholder 1"/>
+          <p:cNvSpPr>
+            <a:spLocks noGrp="1" noRot="1" noChangeAspect="1"/>
+          </p:cNvSpPr>
+          <p:nvPr>
+            <p:ph type="sldImg"/>
+          </p:nvPr>
+        </p:nvSpPr>
+        <p:spPr/>
+      </p:sp>
+      <p:sp>
+        <p:nvSpPr>
+          <p:cNvPr id="3" name="Notes Placeholder 2"/>
+          <p:cNvSpPr>
+            <a:spLocks noGrp="1"/>
+          </p:cNvSpPr>
+          <p:nvPr>
+            <p:ph type="body" idx="1"/>
+          </p:nvPr>
+        </p:nvSpPr>
+        <p:spPr/>
+        <p:txBody>
+          <a:bodyPr/>
+          <a:lstStyle/>
+          <a:p>
+            <a:r>
+              <a:rPr lang="en-US" dirty="0"/>
+              <a:t/>
+            </a:r>
+            <a:endParaRPr lang="en-US" dirty="0"/>
+          </a:p>
+        </p:txBody>
+      </p:sp>
+      <p:sp>
+        <p:nvSpPr>
+          <p:cNvPr id="4" name="Slide Number Placeholder 3"/>
+          <p:cNvSpPr>
+            <a:spLocks noGrp="1"/>
+          </p:cNvSpPr>
+          <p:nvPr>
+            <p:ph type="sldNum" sz="quarter" idx="10"/>
+          </p:nvPr>
+        </p:nvSpPr>
+        <p:spPr/>
+        <p:txBody>
+          <a:bodyPr/>
+          <a:lstStyle/>
+          <a:p>
+            <a:fld id="{F7021451-1387-4CA6-816F-3879F97B5CBC}" type="slidenum">
+              <a:rPr lang="en-US"/>
+              <a:t>13</a:t>
+            </a:fld>
+            <a:endParaRPr lang="en-US"/>
+          </a:p>
+        </p:txBody>
+      </p:sp>
+    </p:spTree>
+    <p:extLst>
+      <p:ext uri="{BB962C8B-B14F-4D97-AF65-F5344CB8AC3E}">
+        <p14:creationId xmlns:p14="http://schemas.microsoft.com/office/powerpoint/2010/main" val="1024086991"/>
+      </p:ext>
+    </p:extLst>
+  </p:cSld>
+  <p:clrMapOvr>
+    <a:masterClrMapping/>
+  </p:clrMapOvr>
+</p:notes>
+</file>
+
+<file path=ppt/notesSlides/notesSlide14.xml><?xml version="1.0" encoding="utf-8"?>
+<p:notes xmlns:a="http://schemas.openxmlformats.org/drawingml/2006/main" xmlns:r="http://schemas.openxmlformats.org/officeDocument/2006/relationships" xmlns:p="http://schemas.openxmlformats.org/presentationml/2006/main">
+  <p:cSld>
+    <p:spTree>
+      <p:nvGrpSpPr>
+        <p:cNvPr id="1" name=""/>
+        <p:cNvGrpSpPr/>
+        <p:nvPr/>
+      </p:nvGrpSpPr>
+      <p:grpSpPr>
+        <a:xfrm>
+          <a:off x="0" y="0"/>
+          <a:ext cx="0" cy="0"/>
+          <a:chOff x="0" y="0"/>
+          <a:chExt cx="0" cy="0"/>
+        </a:xfrm>
+      </p:grpSpPr>
+      <p:sp>
+        <p:nvSpPr>
+          <p:cNvPr id="2" name="Slide Image Placeholder 1"/>
+          <p:cNvSpPr>
+            <a:spLocks noGrp="1" noRot="1" noChangeAspect="1"/>
+          </p:cNvSpPr>
+          <p:nvPr>
+            <p:ph type="sldImg"/>
+          </p:nvPr>
+        </p:nvSpPr>
+        <p:spPr/>
+      </p:sp>
+      <p:sp>
+        <p:nvSpPr>
+          <p:cNvPr id="3" name="Notes Placeholder 2"/>
+          <p:cNvSpPr>
+            <a:spLocks noGrp="1"/>
+          </p:cNvSpPr>
+          <p:nvPr>
+            <p:ph type="body" idx="1"/>
+          </p:nvPr>
+        </p:nvSpPr>
+        <p:spPr/>
+        <p:txBody>
+          <a:bodyPr/>
+          <a:lstStyle/>
+          <a:p>
+            <a:r>
+              <a:rPr lang="en-US" dirty="0"/>
+              <a:t/>
+            </a:r>
+            <a:endParaRPr lang="en-US" dirty="0"/>
+          </a:p>
+        </p:txBody>
+      </p:sp>
+      <p:sp>
+        <p:nvSpPr>
+          <p:cNvPr id="4" name="Slide Number Placeholder 3"/>
+          <p:cNvSpPr>
+            <a:spLocks noGrp="1"/>
+          </p:cNvSpPr>
+          <p:nvPr>
+            <p:ph type="sldNum" sz="quarter" idx="10"/>
+          </p:nvPr>
+        </p:nvSpPr>
+        <p:spPr/>
+        <p:txBody>
+          <a:bodyPr/>
+          <a:lstStyle/>
+          <a:p>
+            <a:fld id="{F7021451-1387-4CA6-816F-3879F97B5CBC}" type="slidenum">
+              <a:rPr lang="en-US"/>
+              <a:t>14</a:t>
             </a:fld>
             <a:endParaRPr lang="en-US"/>
           </a:p>
@@ -4633,6 +5078,1664 @@
 </p:sld>
 </file>
 
+<file path=ppt/slides/slide13.xml><?xml version="1.0" encoding="utf-8"?>
+<p:sld xmlns:a="http://schemas.openxmlformats.org/drawingml/2006/main" xmlns:r="http://schemas.openxmlformats.org/officeDocument/2006/relationships" xmlns:p="http://schemas.openxmlformats.org/presentationml/2006/main">
+  <p:cSld name="Slide 13">
+    <p:bg>
+      <p:bgPr>
+        <a:solidFill>
+          <a:srgbClr val="0D1117"/>
+        </a:solidFill>
+      </p:bgPr>
+    </p:bg>
+    <p:spTree>
+      <p:nvGrpSpPr>
+        <p:cNvPr id="1" name=""/>
+        <p:cNvGrpSpPr/>
+        <p:nvPr/>
+      </p:nvGrpSpPr>
+      <p:grpSpPr>
+        <a:xfrm>
+          <a:off x="0" y="0"/>
+          <a:ext cx="0" cy="0"/>
+          <a:chOff x="0" y="0"/>
+          <a:chExt cx="0" cy="0"/>
+        </a:xfrm>
+      </p:grpSpPr>
+      <p:sp>
+        <p:nvSpPr>
+          <p:cNvPr id="2" name="Text 0"/>
+          <p:cNvSpPr/>
+          <p:nvPr/>
+        </p:nvSpPr>
+        <p:spPr>
+          <a:xfrm>
+            <a:off x="548640" y="384048"/>
+            <a:ext cx="8229600" cy="274320"/>
+          </a:xfrm>
+          <a:prstGeom prst="rect">
+            <a:avLst/>
+          </a:prstGeom>
+          <a:noFill/>
+          <a:ln/>
+        </p:spPr>
+        <p:txBody>
+          <a:bodyPr wrap="square" lIns="0" tIns="0" rIns="0" bIns="0" rtlCol="0" anchor="ctr"/>
+          <a:lstStyle/>
+          <a:p>
+            <a:pPr indent="0" marL="0">
+              <a:buNone/>
+            </a:pPr>
+            <a:r>
+              <a:rPr lang="en-US" sz="1300" b="1" spc="200" kern="0" dirty="0">
+                <a:solidFill>
+                  <a:srgbClr val="FFA657"/>
+                </a:solidFill>
+                <a:latin typeface="Calibri" pitchFamily="34" charset="0"/>
+                <a:ea typeface="Calibri" pitchFamily="34" charset="-122"/>
+                <a:cs typeface="Calibri" pitchFamily="34" charset="-120"/>
+              </a:rPr>
+              <a:t>APPENDIX ①</a:t>
+            </a:r>
+            <a:endParaRPr lang="en-US" sz="1300" dirty="0"/>
+          </a:p>
+        </p:txBody>
+      </p:sp>
+      <p:sp>
+        <p:nvSpPr>
+          <p:cNvPr id="3" name="Text 1"/>
+          <p:cNvSpPr/>
+          <p:nvPr/>
+        </p:nvSpPr>
+        <p:spPr>
+          <a:xfrm>
+            <a:off x="548640" y="676656"/>
+            <a:ext cx="9052560" cy="566928"/>
+          </a:xfrm>
+          <a:prstGeom prst="rect">
+            <a:avLst/>
+          </a:prstGeom>
+          <a:noFill/>
+          <a:ln/>
+        </p:spPr>
+        <p:txBody>
+          <a:bodyPr wrap="square" lIns="0" tIns="0" rIns="0" bIns="0" rtlCol="0" anchor="ctr"/>
+          <a:lstStyle/>
+          <a:p>
+            <a:pPr indent="0" marL="0">
+              <a:buNone/>
+            </a:pPr>
+            <a:r>
+              <a:rPr lang="en-US" sz="2800" b="1" dirty="0">
+                <a:solidFill>
+                  <a:srgbClr val="E6EDF3"/>
+                </a:solidFill>
+                <a:latin typeface="Calibri" pitchFamily="34" charset="0"/>
+                <a:ea typeface="Calibri" pitchFamily="34" charset="-122"/>
+                <a:cs typeface="Calibri" pitchFamily="34" charset="-120"/>
+              </a:rPr>
+              <a:t>train.py가 저장한 model.json 구조</a:t>
+            </a:r>
+            <a:endParaRPr lang="en-US" sz="2800" dirty="0"/>
+          </a:p>
+        </p:txBody>
+      </p:sp>
+      <p:sp>
+        <p:nvSpPr>
+          <p:cNvPr id="4" name="Text 2"/>
+          <p:cNvSpPr/>
+          <p:nvPr/>
+        </p:nvSpPr>
+        <p:spPr>
+          <a:xfrm>
+            <a:off x="10012680" y="457200"/>
+            <a:ext cx="1645920" cy="457200"/>
+          </a:xfrm>
+          <a:prstGeom prst="roundRect">
+            <a:avLst>
+              <a:gd name="adj" fmla="val 16000"/>
+            </a:avLst>
+          </a:prstGeom>
+          <a:solidFill>
+            <a:srgbClr val="161B22"/>
+          </a:solidFill>
+          <a:ln w="12700">
+            <a:solidFill>
+              <a:srgbClr val="30363D"/>
+            </a:solidFill>
+          </a:ln>
+        </p:spPr>
+        <p:txBody>
+          <a:bodyPr wrap="square" lIns="0" tIns="0" rIns="0" bIns="0" rtlCol="0" anchor="ctr"/>
+          <a:lstStyle/>
+          <a:p>
+            <a:pPr algn="ctr" indent="0" marL="0">
+              <a:buNone/>
+            </a:pPr>
+            <a:r>
+              <a:rPr lang="en-US" sz="1300" b="1" dirty="0">
+                <a:solidFill>
+                  <a:srgbClr val="F2CC60"/>
+                </a:solidFill>
+                <a:latin typeface="Courier New" pitchFamily="34" charset="0"/>
+                <a:ea typeface="Courier New" pitchFamily="34" charset="-122"/>
+                <a:cs typeface="Courier New" pitchFamily="34" charset="-120"/>
+              </a:rPr>
+              <a:t>88 KB</a:t>
+            </a:r>
+            <a:endParaRPr lang="en-US" sz="1300" dirty="0"/>
+          </a:p>
+        </p:txBody>
+      </p:sp>
+      <p:sp>
+        <p:nvSpPr>
+          <p:cNvPr id="5" name="Shape 3"/>
+          <p:cNvSpPr/>
+          <p:nvPr/>
+        </p:nvSpPr>
+        <p:spPr>
+          <a:xfrm>
+            <a:off x="548640" y="1554480"/>
+            <a:ext cx="6583680" cy="4480560"/>
+          </a:xfrm>
+          <a:prstGeom prst="roundRect">
+            <a:avLst>
+              <a:gd name="adj" fmla="val 1224"/>
+            </a:avLst>
+          </a:prstGeom>
+          <a:solidFill>
+            <a:srgbClr val="161B22"/>
+          </a:solidFill>
+          <a:ln w="12700">
+            <a:solidFill>
+              <a:srgbClr val="30363D"/>
+            </a:solidFill>
+            <a:prstDash val="solid"/>
+          </a:ln>
+        </p:spPr>
+      </p:sp>
+      <p:sp>
+        <p:nvSpPr>
+          <p:cNvPr id="6" name="Text 4"/>
+          <p:cNvSpPr/>
+          <p:nvPr/>
+        </p:nvSpPr>
+        <p:spPr>
+          <a:xfrm>
+            <a:off x="713232" y="1682496"/>
+            <a:ext cx="6254496" cy="4224528"/>
+          </a:xfrm>
+          <a:prstGeom prst="rect">
+            <a:avLst/>
+          </a:prstGeom>
+          <a:noFill/>
+          <a:ln/>
+        </p:spPr>
+        <p:txBody>
+          <a:bodyPr wrap="square" lIns="0" tIns="0" rIns="0" bIns="0" rtlCol="0" anchor="t"/>
+          <a:lstStyle/>
+          <a:p>
+            <a:pPr algn="l" indent="0" marL="0">
+              <a:lnSpc>
+                <a:spcPct val="105000"/>
+              </a:lnSpc>
+              <a:buNone/>
+            </a:pPr>
+            <a:r>
+              <a:rPr lang="en-US" sz="1200" dirty="0">
+                <a:solidFill>
+                  <a:srgbClr val="8B949E"/>
+                </a:solidFill>
+                <a:latin typeface="Courier New" pitchFamily="34" charset="0"/>
+                <a:ea typeface="Courier New" pitchFamily="34" charset="-122"/>
+                <a:cs typeface="Courier New" pitchFamily="34" charset="-120"/>
+              </a:rPr>
+              <a:t>     </a:t>
+            </a:r>
+            <a:pPr algn="l" indent="0" marL="0">
+              <a:lnSpc>
+                <a:spcPct val="105000"/>
+              </a:lnSpc>
+              <a:buNone/>
+            </a:pPr>
+            <a:r>
+              <a:rPr lang="en-US" sz="1200" b="1" dirty="0">
+                <a:solidFill>
+                  <a:srgbClr val="E6EDF3"/>
+                </a:solidFill>
+                <a:latin typeface="Courier New" pitchFamily="34" charset="0"/>
+                <a:ea typeface="Courier New" pitchFamily="34" charset="-122"/>
+                <a:cs typeface="Courier New" pitchFamily="34" charset="-120"/>
+              </a:rPr>
+              <a:t>{</a:t>
+            </a:r>
+            <a:endParaRPr lang="en-US" sz="1200" dirty="0"/>
+          </a:p>
+          <a:p>
+            <a:pPr algn="l" indent="0" marL="0">
+              <a:lnSpc>
+                <a:spcPct val="105000"/>
+              </a:lnSpc>
+              <a:buNone/>
+            </a:pPr>
+            <a:r>
+              <a:rPr lang="en-US" sz="1200" dirty="0">
+                <a:solidFill>
+                  <a:srgbClr val="8B949E"/>
+                </a:solidFill>
+                <a:latin typeface="Courier New" pitchFamily="34" charset="0"/>
+                <a:ea typeface="Courier New" pitchFamily="34" charset="-122"/>
+                <a:cs typeface="Courier New" pitchFamily="34" charset="-120"/>
+              </a:rPr>
+              <a:t>     </a:t>
+            </a:r>
+            <a:pPr algn="l" indent="0" marL="0">
+              <a:lnSpc>
+                <a:spcPct val="105000"/>
+              </a:lnSpc>
+              <a:buNone/>
+            </a:pPr>
+            <a:r>
+              <a:rPr lang="en-US" sz="1200" b="1" dirty="0">
+                <a:solidFill>
+                  <a:srgbClr val="58A6FF"/>
+                </a:solidFill>
+                <a:latin typeface="Courier New" pitchFamily="34" charset="0"/>
+                <a:ea typeface="Courier New" pitchFamily="34" charset="-122"/>
+                <a:cs typeface="Courier New" pitchFamily="34" charset="-120"/>
+              </a:rPr>
+              <a:t>  "config": {</a:t>
+            </a:r>
+            <a:endParaRPr lang="en-US" sz="1200" dirty="0"/>
+          </a:p>
+          <a:p>
+            <a:pPr algn="l" indent="0" marL="0">
+              <a:lnSpc>
+                <a:spcPct val="105000"/>
+              </a:lnSpc>
+              <a:buNone/>
+            </a:pPr>
+            <a:r>
+              <a:rPr lang="en-US" sz="1200" dirty="0">
+                <a:solidFill>
+                  <a:srgbClr val="8B949E"/>
+                </a:solidFill>
+                <a:latin typeface="Courier New" pitchFamily="34" charset="0"/>
+                <a:ea typeface="Courier New" pitchFamily="34" charset="-122"/>
+                <a:cs typeface="Courier New" pitchFamily="34" charset="-120"/>
+              </a:rPr>
+              <a:t>     </a:t>
+            </a:r>
+            <a:pPr algn="l" indent="0" marL="0">
+              <a:lnSpc>
+                <a:spcPct val="105000"/>
+              </a:lnSpc>
+              <a:buNone/>
+            </a:pPr>
+            <a:r>
+              <a:rPr lang="en-US" sz="1200" dirty="0">
+                <a:solidFill>
+                  <a:srgbClr val="E6EDF3"/>
+                </a:solidFill>
+                <a:latin typeface="Courier New" pitchFamily="34" charset="0"/>
+                <a:ea typeface="Courier New" pitchFamily="34" charset="-122"/>
+                <a:cs typeface="Courier New" pitchFamily="34" charset="-120"/>
+              </a:rPr>
+              <a:t>    "n_embd": 16, "n_head": 4,</a:t>
+            </a:r>
+            <a:endParaRPr lang="en-US" sz="1200" dirty="0"/>
+          </a:p>
+          <a:p>
+            <a:pPr algn="l" indent="0" marL="0">
+              <a:lnSpc>
+                <a:spcPct val="105000"/>
+              </a:lnSpc>
+              <a:buNone/>
+            </a:pPr>
+            <a:r>
+              <a:rPr lang="en-US" sz="1200" dirty="0">
+                <a:solidFill>
+                  <a:srgbClr val="8B949E"/>
+                </a:solidFill>
+                <a:latin typeface="Courier New" pitchFamily="34" charset="0"/>
+                <a:ea typeface="Courier New" pitchFamily="34" charset="-122"/>
+                <a:cs typeface="Courier New" pitchFamily="34" charset="-120"/>
+              </a:rPr>
+              <a:t>     </a:t>
+            </a:r>
+            <a:pPr algn="l" indent="0" marL="0">
+              <a:lnSpc>
+                <a:spcPct val="105000"/>
+              </a:lnSpc>
+              <a:buNone/>
+            </a:pPr>
+            <a:r>
+              <a:rPr lang="en-US" sz="1200" dirty="0">
+                <a:solidFill>
+                  <a:srgbClr val="E6EDF3"/>
+                </a:solidFill>
+                <a:latin typeface="Courier New" pitchFamily="34" charset="0"/>
+                <a:ea typeface="Courier New" pitchFamily="34" charset="-122"/>
+                <a:cs typeface="Courier New" pitchFamily="34" charset="-120"/>
+              </a:rPr>
+              <a:t>    "n_layer": 1, "block_size": 8,</a:t>
+            </a:r>
+            <a:endParaRPr lang="en-US" sz="1200" dirty="0"/>
+          </a:p>
+          <a:p>
+            <a:pPr algn="l" indent="0" marL="0">
+              <a:lnSpc>
+                <a:spcPct val="105000"/>
+              </a:lnSpc>
+              <a:buNone/>
+            </a:pPr>
+            <a:r>
+              <a:rPr lang="en-US" sz="1200" dirty="0">
+                <a:solidFill>
+                  <a:srgbClr val="8B949E"/>
+                </a:solidFill>
+                <a:latin typeface="Courier New" pitchFamily="34" charset="0"/>
+                <a:ea typeface="Courier New" pitchFamily="34" charset="-122"/>
+                <a:cs typeface="Courier New" pitchFamily="34" charset="-120"/>
+              </a:rPr>
+              <a:t>     </a:t>
+            </a:r>
+            <a:pPr algn="l" indent="0" marL="0">
+              <a:lnSpc>
+                <a:spcPct val="105000"/>
+              </a:lnSpc>
+              <a:buNone/>
+            </a:pPr>
+            <a:r>
+              <a:rPr lang="en-US" sz="1200" dirty="0">
+                <a:solidFill>
+                  <a:srgbClr val="E6EDF3"/>
+                </a:solidFill>
+                <a:latin typeface="Courier New" pitchFamily="34" charset="0"/>
+                <a:ea typeface="Courier New" pitchFamily="34" charset="-122"/>
+                <a:cs typeface="Courier New" pitchFamily="34" charset="-120"/>
+              </a:rPr>
+              <a:t>    "vocab_size": 27 },</a:t>
+            </a:r>
+            <a:endParaRPr lang="en-US" sz="1200" dirty="0"/>
+          </a:p>
+          <a:p>
+            <a:pPr algn="l" indent="0" marL="0">
+              <a:lnSpc>
+                <a:spcPct val="105000"/>
+              </a:lnSpc>
+              <a:buNone/>
+            </a:pPr>
+            <a:r>
+              <a:rPr lang="en-US" sz="1200" dirty="0">
+                <a:solidFill>
+                  <a:srgbClr val="8B949E"/>
+                </a:solidFill>
+                <a:latin typeface="Courier New" pitchFamily="34" charset="0"/>
+                <a:ea typeface="Courier New" pitchFamily="34" charset="-122"/>
+                <a:cs typeface="Courier New" pitchFamily="34" charset="-120"/>
+              </a:rPr>
+              <a:t>     </a:t>
+            </a:r>
+            <a:pPr algn="l" indent="0" marL="0">
+              <a:lnSpc>
+                <a:spcPct val="105000"/>
+              </a:lnSpc>
+              <a:buNone/>
+            </a:pPr>
+            <a:r>
+              <a:rPr lang="en-US" sz="1200" b="1" dirty="0">
+                <a:solidFill>
+                  <a:srgbClr val="7EE787"/>
+                </a:solidFill>
+                <a:latin typeface="Courier New" pitchFamily="34" charset="0"/>
+                <a:ea typeface="Courier New" pitchFamily="34" charset="-122"/>
+                <a:cs typeface="Courier New" pitchFamily="34" charset="-120"/>
+              </a:rPr>
+              <a:t>  "chars": ["&lt;BOS&gt;","a","b",</a:t>
+            </a:r>
+            <a:endParaRPr lang="en-US" sz="1200" dirty="0"/>
+          </a:p>
+          <a:p>
+            <a:pPr algn="l" indent="0" marL="0">
+              <a:lnSpc>
+                <a:spcPct val="105000"/>
+              </a:lnSpc>
+              <a:buNone/>
+            </a:pPr>
+            <a:r>
+              <a:rPr lang="en-US" sz="1200" dirty="0">
+                <a:solidFill>
+                  <a:srgbClr val="8B949E"/>
+                </a:solidFill>
+                <a:latin typeface="Courier New" pitchFamily="34" charset="0"/>
+                <a:ea typeface="Courier New" pitchFamily="34" charset="-122"/>
+                <a:cs typeface="Courier New" pitchFamily="34" charset="-120"/>
+              </a:rPr>
+              <a:t>     </a:t>
+            </a:r>
+            <a:pPr algn="l" indent="0" marL="0">
+              <a:lnSpc>
+                <a:spcPct val="105000"/>
+              </a:lnSpc>
+              <a:buNone/>
+            </a:pPr>
+            <a:r>
+              <a:rPr lang="en-US" sz="1200" dirty="0">
+                <a:solidFill>
+                  <a:srgbClr val="7EE787"/>
+                </a:solidFill>
+                <a:latin typeface="Courier New" pitchFamily="34" charset="0"/>
+                <a:ea typeface="Courier New" pitchFamily="34" charset="-122"/>
+                <a:cs typeface="Courier New" pitchFamily="34" charset="-120"/>
+              </a:rPr>
+              <a:t>            ..., "z"],  # 27개</a:t>
+            </a:r>
+            <a:endParaRPr lang="en-US" sz="1200" dirty="0"/>
+          </a:p>
+          <a:p>
+            <a:pPr algn="l" indent="0" marL="0">
+              <a:lnSpc>
+                <a:spcPct val="105000"/>
+              </a:lnSpc>
+              <a:buNone/>
+            </a:pPr>
+            <a:r>
+              <a:rPr lang="en-US" sz="1200" dirty="0">
+                <a:solidFill>
+                  <a:srgbClr val="8B949E"/>
+                </a:solidFill>
+                <a:latin typeface="Courier New" pitchFamily="34" charset="0"/>
+                <a:ea typeface="Courier New" pitchFamily="34" charset="-122"/>
+                <a:cs typeface="Courier New" pitchFamily="34" charset="-120"/>
+              </a:rPr>
+              <a:t>     </a:t>
+            </a:r>
+            <a:pPr algn="l" indent="0" marL="0">
+              <a:lnSpc>
+                <a:spcPct val="105000"/>
+              </a:lnSpc>
+              <a:buNone/>
+            </a:pPr>
+            <a:r>
+              <a:rPr lang="en-US" sz="1200" b="1" dirty="0">
+                <a:solidFill>
+                  <a:srgbClr val="D2A8FF"/>
+                </a:solidFill>
+                <a:latin typeface="Courier New" pitchFamily="34" charset="0"/>
+                <a:ea typeface="Courier New" pitchFamily="34" charset="-122"/>
+                <a:cs typeface="Courier New" pitchFamily="34" charset="-120"/>
+              </a:rPr>
+              <a:t>  "weights": {</a:t>
+            </a:r>
+            <a:endParaRPr lang="en-US" sz="1200" dirty="0"/>
+          </a:p>
+          <a:p>
+            <a:pPr algn="l" indent="0" marL="0">
+              <a:lnSpc>
+                <a:spcPct val="105000"/>
+              </a:lnSpc>
+              <a:buNone/>
+            </a:pPr>
+            <a:r>
+              <a:rPr lang="en-US" sz="1200" dirty="0">
+                <a:solidFill>
+                  <a:srgbClr val="8B949E"/>
+                </a:solidFill>
+                <a:latin typeface="Courier New" pitchFamily="34" charset="0"/>
+                <a:ea typeface="Courier New" pitchFamily="34" charset="-122"/>
+                <a:cs typeface="Courier New" pitchFamily="34" charset="-120"/>
+              </a:rPr>
+              <a:t>     </a:t>
+            </a:r>
+            <a:pPr algn="l" indent="0" marL="0">
+              <a:lnSpc>
+                <a:spcPct val="105000"/>
+              </a:lnSpc>
+              <a:buNone/>
+            </a:pPr>
+            <a:r>
+              <a:rPr lang="en-US" sz="1200" dirty="0">
+                <a:solidFill>
+                  <a:srgbClr val="E6EDF3"/>
+                </a:solidFill>
+                <a:latin typeface="Courier New" pitchFamily="34" charset="0"/>
+                <a:ea typeface="Courier New" pitchFamily="34" charset="-122"/>
+                <a:cs typeface="Courier New" pitchFamily="34" charset="-120"/>
+              </a:rPr>
+              <a:t>    "wte":  [[27x16]],</a:t>
+            </a:r>
+            <a:endParaRPr lang="en-US" sz="1200" dirty="0"/>
+          </a:p>
+          <a:p>
+            <a:pPr algn="l" indent="0" marL="0">
+              <a:lnSpc>
+                <a:spcPct val="105000"/>
+              </a:lnSpc>
+              <a:buNone/>
+            </a:pPr>
+            <a:r>
+              <a:rPr lang="en-US" sz="1200" dirty="0">
+                <a:solidFill>
+                  <a:srgbClr val="8B949E"/>
+                </a:solidFill>
+                <a:latin typeface="Courier New" pitchFamily="34" charset="0"/>
+                <a:ea typeface="Courier New" pitchFamily="34" charset="-122"/>
+                <a:cs typeface="Courier New" pitchFamily="34" charset="-120"/>
+              </a:rPr>
+              <a:t>     </a:t>
+            </a:r>
+            <a:pPr algn="l" indent="0" marL="0">
+              <a:lnSpc>
+                <a:spcPct val="105000"/>
+              </a:lnSpc>
+              <a:buNone/>
+            </a:pPr>
+            <a:r>
+              <a:rPr lang="en-US" sz="1200" dirty="0">
+                <a:solidFill>
+                  <a:srgbClr val="E6EDF3"/>
+                </a:solidFill>
+                <a:latin typeface="Courier New" pitchFamily="34" charset="0"/>
+                <a:ea typeface="Courier New" pitchFamily="34" charset="-122"/>
+                <a:cs typeface="Courier New" pitchFamily="34" charset="-120"/>
+              </a:rPr>
+              <a:t>    "wpe":  [[8x16]],</a:t>
+            </a:r>
+            <a:endParaRPr lang="en-US" sz="1200" dirty="0"/>
+          </a:p>
+          <a:p>
+            <a:pPr algn="l" indent="0" marL="0">
+              <a:lnSpc>
+                <a:spcPct val="105000"/>
+              </a:lnSpc>
+              <a:buNone/>
+            </a:pPr>
+            <a:r>
+              <a:rPr lang="en-US" sz="1200" dirty="0">
+                <a:solidFill>
+                  <a:srgbClr val="8B949E"/>
+                </a:solidFill>
+                <a:latin typeface="Courier New" pitchFamily="34" charset="0"/>
+                <a:ea typeface="Courier New" pitchFamily="34" charset="-122"/>
+                <a:cs typeface="Courier New" pitchFamily="34" charset="-120"/>
+              </a:rPr>
+              <a:t>     </a:t>
+            </a:r>
+            <a:pPr algn="l" indent="0" marL="0">
+              <a:lnSpc>
+                <a:spcPct val="105000"/>
+              </a:lnSpc>
+              <a:buNone/>
+            </a:pPr>
+            <a:r>
+              <a:rPr lang="en-US" sz="1200" dirty="0">
+                <a:solidFill>
+                  <a:srgbClr val="E6EDF3"/>
+                </a:solidFill>
+                <a:latin typeface="Courier New" pitchFamily="34" charset="0"/>
+                <a:ea typeface="Courier New" pitchFamily="34" charset="-122"/>
+                <a:cs typeface="Courier New" pitchFamily="34" charset="-120"/>
+              </a:rPr>
+              <a:t>    "lm_head": [[27x16]],</a:t>
+            </a:r>
+            <a:endParaRPr lang="en-US" sz="1200" dirty="0"/>
+          </a:p>
+          <a:p>
+            <a:pPr algn="l" indent="0" marL="0">
+              <a:lnSpc>
+                <a:spcPct val="105000"/>
+              </a:lnSpc>
+              <a:buNone/>
+            </a:pPr>
+            <a:r>
+              <a:rPr lang="en-US" sz="1200" dirty="0">
+                <a:solidFill>
+                  <a:srgbClr val="8B949E"/>
+                </a:solidFill>
+                <a:latin typeface="Courier New" pitchFamily="34" charset="0"/>
+                <a:ea typeface="Courier New" pitchFamily="34" charset="-122"/>
+                <a:cs typeface="Courier New" pitchFamily="34" charset="-120"/>
+              </a:rPr>
+              <a:t>     </a:t>
+            </a:r>
+            <a:pPr algn="l" indent="0" marL="0">
+              <a:lnSpc>
+                <a:spcPct val="105000"/>
+              </a:lnSpc>
+              <a:buNone/>
+            </a:pPr>
+            <a:r>
+              <a:rPr lang="en-US" sz="1200" dirty="0">
+                <a:solidFill>
+                  <a:srgbClr val="E6EDF3"/>
+                </a:solidFill>
+                <a:latin typeface="Courier New" pitchFamily="34" charset="0"/>
+                <a:ea typeface="Courier New" pitchFamily="34" charset="-122"/>
+                <a:cs typeface="Courier New" pitchFamily="34" charset="-120"/>
+              </a:rPr>
+              <a:t>    "layer0.attn_wq/wk/wv/wo",</a:t>
+            </a:r>
+            <a:endParaRPr lang="en-US" sz="1200" dirty="0"/>
+          </a:p>
+          <a:p>
+            <a:pPr algn="l" indent="0" marL="0">
+              <a:lnSpc>
+                <a:spcPct val="105000"/>
+              </a:lnSpc>
+              <a:buNone/>
+            </a:pPr>
+            <a:r>
+              <a:rPr lang="en-US" sz="1200" dirty="0">
+                <a:solidFill>
+                  <a:srgbClr val="8B949E"/>
+                </a:solidFill>
+                <a:latin typeface="Courier New" pitchFamily="34" charset="0"/>
+                <a:ea typeface="Courier New" pitchFamily="34" charset="-122"/>
+                <a:cs typeface="Courier New" pitchFamily="34" charset="-120"/>
+              </a:rPr>
+              <a:t>     </a:t>
+            </a:r>
+            <a:pPr algn="l" indent="0" marL="0">
+              <a:lnSpc>
+                <a:spcPct val="105000"/>
+              </a:lnSpc>
+              <a:buNone/>
+            </a:pPr>
+            <a:r>
+              <a:rPr lang="en-US" sz="1200" dirty="0">
+                <a:solidFill>
+                  <a:srgbClr val="E6EDF3"/>
+                </a:solidFill>
+                <a:latin typeface="Courier New" pitchFamily="34" charset="0"/>
+                <a:ea typeface="Courier New" pitchFamily="34" charset="-122"/>
+                <a:cs typeface="Courier New" pitchFamily="34" charset="-120"/>
+              </a:rPr>
+              <a:t>    "layer0.mlp_fc1/fc2" }</a:t>
+            </a:r>
+            <a:endParaRPr lang="en-US" sz="1200" dirty="0"/>
+          </a:p>
+          <a:p>
+            <a:pPr algn="l" indent="0" marL="0">
+              <a:lnSpc>
+                <a:spcPct val="105000"/>
+              </a:lnSpc>
+              <a:buNone/>
+            </a:pPr>
+            <a:r>
+              <a:rPr lang="en-US" sz="1200" dirty="0">
+                <a:solidFill>
+                  <a:srgbClr val="8B949E"/>
+                </a:solidFill>
+                <a:latin typeface="Courier New" pitchFamily="34" charset="0"/>
+                <a:ea typeface="Courier New" pitchFamily="34" charset="-122"/>
+                <a:cs typeface="Courier New" pitchFamily="34" charset="-120"/>
+              </a:rPr>
+              <a:t>     </a:t>
+            </a:r>
+            <a:pPr algn="l" indent="0" marL="0">
+              <a:lnSpc>
+                <a:spcPct val="105000"/>
+              </a:lnSpc>
+              <a:buNone/>
+            </a:pPr>
+            <a:r>
+              <a:rPr lang="en-US" sz="1200" b="1" dirty="0">
+                <a:solidFill>
+                  <a:srgbClr val="E6EDF3"/>
+                </a:solidFill>
+                <a:latin typeface="Courier New" pitchFamily="34" charset="0"/>
+                <a:ea typeface="Courier New" pitchFamily="34" charset="-122"/>
+                <a:cs typeface="Courier New" pitchFamily="34" charset="-120"/>
+              </a:rPr>
+              <a:t>}</a:t>
+            </a:r>
+            <a:endParaRPr lang="en-US" sz="1200" dirty="0"/>
+          </a:p>
+        </p:txBody>
+      </p:sp>
+      <p:sp>
+        <p:nvSpPr>
+          <p:cNvPr id="7" name="Shape 5"/>
+          <p:cNvSpPr/>
+          <p:nvPr/>
+        </p:nvSpPr>
+        <p:spPr>
+          <a:xfrm>
+            <a:off x="7360920" y="1554480"/>
+            <a:ext cx="4251960" cy="1463040"/>
+          </a:xfrm>
+          <a:prstGeom prst="roundRect">
+            <a:avLst>
+              <a:gd name="adj" fmla="val 3750"/>
+            </a:avLst>
+          </a:prstGeom>
+          <a:solidFill>
+            <a:srgbClr val="1C2128"/>
+          </a:solidFill>
+          <a:ln w="12700">
+            <a:solidFill>
+              <a:srgbClr val="30363D"/>
+            </a:solidFill>
+            <a:prstDash val="solid"/>
+          </a:ln>
+        </p:spPr>
+      </p:sp>
+      <p:sp>
+        <p:nvSpPr>
+          <p:cNvPr id="8" name="Text 6"/>
+          <p:cNvSpPr/>
+          <p:nvPr/>
+        </p:nvSpPr>
+        <p:spPr>
+          <a:xfrm>
+            <a:off x="7562088" y="1682496"/>
+            <a:ext cx="3849624" cy="310896"/>
+          </a:xfrm>
+          <a:prstGeom prst="rect">
+            <a:avLst/>
+          </a:prstGeom>
+          <a:noFill/>
+          <a:ln/>
+        </p:spPr>
+        <p:txBody>
+          <a:bodyPr wrap="square" lIns="0" tIns="0" rIns="0" bIns="0" rtlCol="0" anchor="ctr"/>
+          <a:lstStyle/>
+          <a:p>
+            <a:pPr indent="0" marL="0">
+              <a:buNone/>
+            </a:pPr>
+            <a:r>
+              <a:rPr lang="en-US" sz="1400" b="1" dirty="0">
+                <a:solidFill>
+                  <a:srgbClr val="FFA657"/>
+                </a:solidFill>
+                <a:latin typeface="Calibri" pitchFamily="34" charset="0"/>
+                <a:ea typeface="Calibri" pitchFamily="34" charset="-122"/>
+                <a:cs typeface="Calibri" pitchFamily="34" charset="-120"/>
+              </a:rPr>
+              <a:t>L269–282에서 생성</a:t>
+            </a:r>
+            <a:endParaRPr lang="en-US" sz="1400" dirty="0"/>
+          </a:p>
+        </p:txBody>
+      </p:sp>
+      <p:sp>
+        <p:nvSpPr>
+          <p:cNvPr id="9" name="Text 7"/>
+          <p:cNvSpPr/>
+          <p:nvPr/>
+        </p:nvSpPr>
+        <p:spPr>
+          <a:xfrm>
+            <a:off x="7580376" y="2029968"/>
+            <a:ext cx="3831336" cy="859536"/>
+          </a:xfrm>
+          <a:prstGeom prst="rect">
+            <a:avLst/>
+          </a:prstGeom>
+          <a:noFill/>
+          <a:ln/>
+        </p:spPr>
+        <p:txBody>
+          <a:bodyPr wrap="square" lIns="0" tIns="0" rIns="0" bIns="0" rtlCol="0" anchor="t"/>
+          <a:lstStyle/>
+          <a:p>
+            <a:pPr marL="342900" indent="-342900">
+              <a:spcAft>
+                <a:spcPts val="400"/>
+              </a:spcAft>
+              <a:buSzPct val="100000"/>
+              <a:buChar char="•"/>
+            </a:pPr>
+            <a:r>
+              <a:rPr lang="en-US" sz="1250" dirty="0">
+                <a:solidFill>
+                  <a:srgbClr val="E6EDF3"/>
+                </a:solidFill>
+                <a:latin typeface="Calibri" pitchFamily="34" charset="0"/>
+                <a:ea typeface="Calibri" pitchFamily="34" charset="-122"/>
+                <a:cs typeface="Calibri" pitchFamily="34" charset="-120"/>
+              </a:rPr>
+              <a:t>config·chars·weights를 dict로 조립</a:t>
+            </a:r>
+            <a:endParaRPr lang="en-US" sz="1250" dirty="0"/>
+          </a:p>
+          <a:p>
+            <a:pPr marL="342900" indent="-342900">
+              <a:spcAft>
+                <a:spcPts val="400"/>
+              </a:spcAft>
+              <a:buSzPct val="100000"/>
+              <a:buChar char="•"/>
+            </a:pPr>
+            <a:r>
+              <a:rPr lang="en-US" sz="1250" dirty="0">
+                <a:solidFill>
+                  <a:srgbClr val="E6EDF3"/>
+                </a:solidFill>
+                <a:latin typeface="Calibri" pitchFamily="34" charset="0"/>
+                <a:ea typeface="Calibri" pitchFamily="34" charset="-122"/>
+                <a:cs typeface="Calibri" pitchFamily="34" charset="-120"/>
+              </a:rPr>
+              <a:t>json.dump로 파일에 직렬화</a:t>
+            </a:r>
+            <a:endParaRPr lang="en-US" sz="1250" dirty="0"/>
+          </a:p>
+        </p:txBody>
+      </p:sp>
+      <p:sp>
+        <p:nvSpPr>
+          <p:cNvPr id="10" name="Shape 8"/>
+          <p:cNvSpPr/>
+          <p:nvPr/>
+        </p:nvSpPr>
+        <p:spPr>
+          <a:xfrm>
+            <a:off x="7360920" y="3127248"/>
+            <a:ext cx="4251960" cy="1325880"/>
+          </a:xfrm>
+          <a:prstGeom prst="roundRect">
+            <a:avLst>
+              <a:gd name="adj" fmla="val 4138"/>
+            </a:avLst>
+          </a:prstGeom>
+          <a:solidFill>
+            <a:srgbClr val="1C2128"/>
+          </a:solidFill>
+          <a:ln w="12700">
+            <a:solidFill>
+              <a:srgbClr val="30363D"/>
+            </a:solidFill>
+            <a:prstDash val="solid"/>
+          </a:ln>
+        </p:spPr>
+      </p:sp>
+      <p:sp>
+        <p:nvSpPr>
+          <p:cNvPr id="11" name="Text 9"/>
+          <p:cNvSpPr/>
+          <p:nvPr/>
+        </p:nvSpPr>
+        <p:spPr>
+          <a:xfrm>
+            <a:off x="7562088" y="3255264"/>
+            <a:ext cx="3849624" cy="310896"/>
+          </a:xfrm>
+          <a:prstGeom prst="rect">
+            <a:avLst/>
+          </a:prstGeom>
+          <a:noFill/>
+          <a:ln/>
+        </p:spPr>
+        <p:txBody>
+          <a:bodyPr wrap="square" lIns="0" tIns="0" rIns="0" bIns="0" rtlCol="0" anchor="ctr"/>
+          <a:lstStyle/>
+          <a:p>
+            <a:pPr indent="0" marL="0">
+              <a:buNone/>
+            </a:pPr>
+            <a:r>
+              <a:rPr lang="en-US" sz="1400" b="1" dirty="0">
+                <a:solidFill>
+                  <a:srgbClr val="7EE787"/>
+                </a:solidFill>
+                <a:latin typeface="Calibri" pitchFamily="34" charset="0"/>
+                <a:ea typeface="Calibri" pitchFamily="34" charset="-122"/>
+                <a:cs typeface="Calibri" pitchFamily="34" charset="-120"/>
+              </a:rPr>
+              <a:t>핵심: Value 벗기기</a:t>
+            </a:r>
+            <a:endParaRPr lang="en-US" sz="1400" dirty="0"/>
+          </a:p>
+        </p:txBody>
+      </p:sp>
+      <p:sp>
+        <p:nvSpPr>
+          <p:cNvPr id="12" name="Text 10"/>
+          <p:cNvSpPr/>
+          <p:nvPr/>
+        </p:nvSpPr>
+        <p:spPr>
+          <a:xfrm>
+            <a:off x="7580376" y="3602736"/>
+            <a:ext cx="3831336" cy="722376"/>
+          </a:xfrm>
+          <a:prstGeom prst="rect">
+            <a:avLst/>
+          </a:prstGeom>
+          <a:noFill/>
+          <a:ln/>
+        </p:spPr>
+        <p:txBody>
+          <a:bodyPr wrap="square" lIns="0" tIns="0" rIns="0" bIns="0" rtlCol="0" anchor="t"/>
+          <a:lstStyle/>
+          <a:p>
+            <a:pPr marL="342900" indent="-342900">
+              <a:spcAft>
+                <a:spcPts val="400"/>
+              </a:spcAft>
+              <a:buSzPct val="100000"/>
+              <a:buChar char="•"/>
+            </a:pPr>
+            <a:r>
+              <a:rPr lang="en-US" sz="1250" dirty="0">
+                <a:solidFill>
+                  <a:srgbClr val="E6EDF3"/>
+                </a:solidFill>
+                <a:latin typeface="Calibri" pitchFamily="34" charset="0"/>
+                <a:ea typeface="Calibri" pitchFamily="34" charset="-122"/>
+                <a:cs typeface="Calibri" pitchFamily="34" charset="-120"/>
+              </a:rPr>
+              <a:t>weights = p.data만 추출 (순수 float)</a:t>
+            </a:r>
+            <a:endParaRPr lang="en-US" sz="1250" dirty="0"/>
+          </a:p>
+          <a:p>
+            <a:pPr marL="342900" indent="-342900">
+              <a:spcAft>
+                <a:spcPts val="400"/>
+              </a:spcAft>
+              <a:buSzPct val="100000"/>
+              <a:buChar char="•"/>
+            </a:pPr>
+            <a:r>
+              <a:rPr lang="en-US" sz="1250" dirty="0">
+                <a:solidFill>
+                  <a:srgbClr val="E6EDF3"/>
+                </a:solidFill>
+                <a:latin typeface="Calibri" pitchFamily="34" charset="0"/>
+                <a:ea typeface="Calibri" pitchFamily="34" charset="-122"/>
+                <a:cs typeface="Calibri" pitchFamily="34" charset="-120"/>
+              </a:rPr>
+              <a:t>기울기·그래프 없이 값만 저장</a:t>
+            </a:r>
+            <a:endParaRPr lang="en-US" sz="1250" dirty="0"/>
+          </a:p>
+        </p:txBody>
+      </p:sp>
+      <p:sp>
+        <p:nvSpPr>
+          <p:cNvPr id="13" name="Shape 11"/>
+          <p:cNvSpPr/>
+          <p:nvPr/>
+        </p:nvSpPr>
+        <p:spPr>
+          <a:xfrm>
+            <a:off x="7360920" y="4572000"/>
+            <a:ext cx="4251960" cy="1463040"/>
+          </a:xfrm>
+          <a:prstGeom prst="roundRect">
+            <a:avLst>
+              <a:gd name="adj" fmla="val 3750"/>
+            </a:avLst>
+          </a:prstGeom>
+          <a:solidFill>
+            <a:srgbClr val="1C2128"/>
+          </a:solidFill>
+          <a:ln w="12700">
+            <a:solidFill>
+              <a:srgbClr val="30363D"/>
+            </a:solidFill>
+            <a:prstDash val="solid"/>
+          </a:ln>
+        </p:spPr>
+      </p:sp>
+      <p:sp>
+        <p:nvSpPr>
+          <p:cNvPr id="14" name="Text 12"/>
+          <p:cNvSpPr/>
+          <p:nvPr/>
+        </p:nvSpPr>
+        <p:spPr>
+          <a:xfrm>
+            <a:off x="7562088" y="4700016"/>
+            <a:ext cx="3849624" cy="310896"/>
+          </a:xfrm>
+          <a:prstGeom prst="rect">
+            <a:avLst/>
+          </a:prstGeom>
+          <a:noFill/>
+          <a:ln/>
+        </p:spPr>
+        <p:txBody>
+          <a:bodyPr wrap="square" lIns="0" tIns="0" rIns="0" bIns="0" rtlCol="0" anchor="ctr"/>
+          <a:lstStyle/>
+          <a:p>
+            <a:pPr indent="0" marL="0">
+              <a:buNone/>
+            </a:pPr>
+            <a:r>
+              <a:rPr lang="en-US" sz="1400" b="1" dirty="0">
+                <a:solidFill>
+                  <a:srgbClr val="D2A8FF"/>
+                </a:solidFill>
+                <a:latin typeface="Calibri" pitchFamily="34" charset="0"/>
+                <a:ea typeface="Calibri" pitchFamily="34" charset="-122"/>
+                <a:cs typeface="Calibri" pitchFamily="34" charset="-120"/>
+              </a:rPr>
+              <a:t>재사용의 3요소</a:t>
+            </a:r>
+            <a:endParaRPr lang="en-US" sz="1400" dirty="0"/>
+          </a:p>
+        </p:txBody>
+      </p:sp>
+      <p:sp>
+        <p:nvSpPr>
+          <p:cNvPr id="15" name="Text 13"/>
+          <p:cNvSpPr/>
+          <p:nvPr/>
+        </p:nvSpPr>
+        <p:spPr>
+          <a:xfrm>
+            <a:off x="7580376" y="5047488"/>
+            <a:ext cx="3831336" cy="859536"/>
+          </a:xfrm>
+          <a:prstGeom prst="rect">
+            <a:avLst/>
+          </a:prstGeom>
+          <a:noFill/>
+          <a:ln/>
+        </p:spPr>
+        <p:txBody>
+          <a:bodyPr wrap="square" lIns="0" tIns="0" rIns="0" bIns="0" rtlCol="0" anchor="t"/>
+          <a:lstStyle/>
+          <a:p>
+            <a:pPr marL="342900" indent="-342900">
+              <a:spcAft>
+                <a:spcPts val="400"/>
+              </a:spcAft>
+              <a:buSzPct val="100000"/>
+              <a:buChar char="•"/>
+            </a:pPr>
+            <a:r>
+              <a:rPr lang="en-US" sz="1250" dirty="0">
+                <a:solidFill>
+                  <a:srgbClr val="E6EDF3"/>
+                </a:solidFill>
+                <a:latin typeface="Calibri" pitchFamily="34" charset="0"/>
+                <a:ea typeface="Calibri" pitchFamily="34" charset="-122"/>
+                <a:cs typeface="Calibri" pitchFamily="34" charset="-120"/>
+              </a:rPr>
+              <a:t>config → 아키텍처 복원</a:t>
+            </a:r>
+            <a:endParaRPr lang="en-US" sz="1250" dirty="0"/>
+          </a:p>
+          <a:p>
+            <a:pPr marL="342900" indent="-342900">
+              <a:spcAft>
+                <a:spcPts val="400"/>
+              </a:spcAft>
+              <a:buSzPct val="100000"/>
+              <a:buChar char="•"/>
+            </a:pPr>
+            <a:r>
+              <a:rPr lang="en-US" sz="1250" dirty="0">
+                <a:solidFill>
+                  <a:srgbClr val="E6EDF3"/>
+                </a:solidFill>
+                <a:latin typeface="Calibri" pitchFamily="34" charset="0"/>
+                <a:ea typeface="Calibri" pitchFamily="34" charset="-122"/>
+                <a:cs typeface="Calibri" pitchFamily="34" charset="-120"/>
+              </a:rPr>
+              <a:t>chars → 토크나이저, weights → 지식</a:t>
+            </a:r>
+            <a:endParaRPr lang="en-US" sz="1250" dirty="0"/>
+          </a:p>
+          <a:p>
+            <a:pPr marL="342900" indent="-342900">
+              <a:spcAft>
+                <a:spcPts val="400"/>
+              </a:spcAft>
+              <a:buSzPct val="100000"/>
+              <a:buChar char="•"/>
+            </a:pPr>
+            <a:r>
+              <a:rPr lang="en-US" sz="1250" dirty="0">
+                <a:solidFill>
+                  <a:srgbClr val="E6EDF3"/>
+                </a:solidFill>
+                <a:latin typeface="Calibri" pitchFamily="34" charset="0"/>
+                <a:ea typeface="Calibri" pitchFamily="34" charset="-122"/>
+                <a:cs typeface="Calibri" pitchFamily="34" charset="-120"/>
+              </a:rPr>
+              <a:t>→ run.py가 이 파일을 그대로 불러 씀</a:t>
+            </a:r>
+            <a:endParaRPr lang="en-US" sz="1250" dirty="0"/>
+          </a:p>
+        </p:txBody>
+      </p:sp>
+    </p:spTree>
+  </p:cSld>
+  <p:clrMapOvr>
+    <a:masterClrMapping/>
+  </p:clrMapOvr>
+</p:sld>
+</file>
+
+<file path=ppt/slides/slide14.xml><?xml version="1.0" encoding="utf-8"?>
+<p:sld xmlns:a="http://schemas.openxmlformats.org/drawingml/2006/main" xmlns:r="http://schemas.openxmlformats.org/officeDocument/2006/relationships" xmlns:p="http://schemas.openxmlformats.org/presentationml/2006/main">
+  <p:cSld name="Slide 14">
+    <p:bg>
+      <p:bgPr>
+        <a:solidFill>
+          <a:srgbClr val="0D1117"/>
+        </a:solidFill>
+      </p:bgPr>
+    </p:bg>
+    <p:spTree>
+      <p:nvGrpSpPr>
+        <p:cNvPr id="1" name=""/>
+        <p:cNvGrpSpPr/>
+        <p:nvPr/>
+      </p:nvGrpSpPr>
+      <p:grpSpPr>
+        <a:xfrm>
+          <a:off x="0" y="0"/>
+          <a:ext cx="0" cy="0"/>
+          <a:chOff x="0" y="0"/>
+          <a:chExt cx="0" cy="0"/>
+        </a:xfrm>
+      </p:grpSpPr>
+      <p:sp>
+        <p:nvSpPr>
+          <p:cNvPr id="2" name="Text 0"/>
+          <p:cNvSpPr/>
+          <p:nvPr/>
+        </p:nvSpPr>
+        <p:spPr>
+          <a:xfrm>
+            <a:off x="548640" y="384048"/>
+            <a:ext cx="8229600" cy="274320"/>
+          </a:xfrm>
+          <a:prstGeom prst="rect">
+            <a:avLst/>
+          </a:prstGeom>
+          <a:noFill/>
+          <a:ln/>
+        </p:spPr>
+        <p:txBody>
+          <a:bodyPr wrap="square" lIns="0" tIns="0" rIns="0" bIns="0" rtlCol="0" anchor="ctr"/>
+          <a:lstStyle/>
+          <a:p>
+            <a:pPr indent="0" marL="0">
+              <a:buNone/>
+            </a:pPr>
+            <a:r>
+              <a:rPr lang="en-US" sz="1300" b="1" spc="200" kern="0" dirty="0">
+                <a:solidFill>
+                  <a:srgbClr val="FFA657"/>
+                </a:solidFill>
+                <a:latin typeface="Calibri" pitchFamily="34" charset="0"/>
+                <a:ea typeface="Calibri" pitchFamily="34" charset="-122"/>
+                <a:cs typeface="Calibri" pitchFamily="34" charset="-120"/>
+              </a:rPr>
+              <a:t>APPENDIX ②</a:t>
+            </a:r>
+            <a:endParaRPr lang="en-US" sz="1300" dirty="0"/>
+          </a:p>
+        </p:txBody>
+      </p:sp>
+      <p:sp>
+        <p:nvSpPr>
+          <p:cNvPr id="3" name="Text 1"/>
+          <p:cNvSpPr/>
+          <p:nvPr/>
+        </p:nvSpPr>
+        <p:spPr>
+          <a:xfrm>
+            <a:off x="548640" y="676656"/>
+            <a:ext cx="9052560" cy="566928"/>
+          </a:xfrm>
+          <a:prstGeom prst="rect">
+            <a:avLst/>
+          </a:prstGeom>
+          <a:noFill/>
+          <a:ln/>
+        </p:spPr>
+        <p:txBody>
+          <a:bodyPr wrap="square" lIns="0" tIns="0" rIns="0" bIns="0" rtlCol="0" anchor="ctr"/>
+          <a:lstStyle/>
+          <a:p>
+            <a:pPr indent="0" marL="0">
+              <a:buNone/>
+            </a:pPr>
+            <a:r>
+              <a:rPr lang="en-US" sz="2800" b="1" dirty="0">
+                <a:solidFill>
+                  <a:srgbClr val="E6EDF3"/>
+                </a:solidFill>
+                <a:latin typeface="Calibri" pitchFamily="34" charset="0"/>
+                <a:ea typeface="Calibri" pitchFamily="34" charset="-122"/>
+                <a:cs typeface="Calibri" pitchFamily="34" charset="-120"/>
+              </a:rPr>
+              <a:t>저장된 가중치 파라미터 분해 — 총 4,064개</a:t>
+            </a:r>
+            <a:endParaRPr lang="en-US" sz="2800" dirty="0"/>
+          </a:p>
+        </p:txBody>
+      </p:sp>
+      <p:sp>
+        <p:nvSpPr>
+          <p:cNvPr id="4" name="Text 2"/>
+          <p:cNvSpPr/>
+          <p:nvPr/>
+        </p:nvSpPr>
+        <p:spPr>
+          <a:xfrm>
+            <a:off x="10012680" y="457200"/>
+            <a:ext cx="1645920" cy="457200"/>
+          </a:xfrm>
+          <a:prstGeom prst="roundRect">
+            <a:avLst>
+              <a:gd name="adj" fmla="val 16000"/>
+            </a:avLst>
+          </a:prstGeom>
+          <a:solidFill>
+            <a:srgbClr val="161B22"/>
+          </a:solidFill>
+          <a:ln w="12700">
+            <a:solidFill>
+              <a:srgbClr val="30363D"/>
+            </a:solidFill>
+          </a:ln>
+        </p:spPr>
+        <p:txBody>
+          <a:bodyPr wrap="square" lIns="0" tIns="0" rIns="0" bIns="0" rtlCol="0" anchor="ctr"/>
+          <a:lstStyle/>
+          <a:p>
+            <a:pPr algn="ctr" indent="0" marL="0">
+              <a:buNone/>
+            </a:pPr>
+            <a:r>
+              <a:rPr lang="en-US" sz="1300" b="1" dirty="0">
+                <a:solidFill>
+                  <a:srgbClr val="F2CC60"/>
+                </a:solidFill>
+                <a:latin typeface="Courier New" pitchFamily="34" charset="0"/>
+                <a:ea typeface="Courier New" pitchFamily="34" charset="-122"/>
+                <a:cs typeface="Courier New" pitchFamily="34" charset="-120"/>
+              </a:rPr>
+              <a:t>9 matrices</a:t>
+            </a:r>
+            <a:endParaRPr lang="en-US" sz="1300" dirty="0"/>
+          </a:p>
+        </p:txBody>
+      </p:sp>
+      <p:sp>
+        <p:nvSpPr>
+          <p:cNvPr id="5" name="Shape 3"/>
+          <p:cNvSpPr/>
+          <p:nvPr/>
+        </p:nvSpPr>
+        <p:spPr>
+          <a:xfrm>
+            <a:off x="548640" y="1600200"/>
+            <a:ext cx="6766560" cy="4343400"/>
+          </a:xfrm>
+          <a:prstGeom prst="roundRect">
+            <a:avLst>
+              <a:gd name="adj" fmla="val 1263"/>
+            </a:avLst>
+          </a:prstGeom>
+          <a:solidFill>
+            <a:srgbClr val="F5F7FA"/>
+          </a:solidFill>
+          <a:ln w="12700">
+            <a:solidFill>
+              <a:srgbClr val="30363D"/>
+            </a:solidFill>
+            <a:prstDash val="solid"/>
+          </a:ln>
+        </p:spPr>
+      </p:sp>
+      <p:graphicFrame>
+        <p:nvGraphicFramePr>
+          <p:cNvPr id="6" name="Chart 0" descr=""/>
+          <p:cNvGraphicFramePr/>
+          <p:nvPr/>
+        </p:nvGraphicFramePr>
+        <p:xfrm>
+          <a:off x="685800" y="1737360"/>
+          <a:ext cx="6492240" cy="4069080"/>
+        </p:xfrm>
+        <a:graphic xmlns:a="http://schemas.openxmlformats.org/drawingml/2006/main">
+          <a:graphicData uri="http://schemas.openxmlformats.org/drawingml/2006/chart">
+            <c:chart xmlns:c="http://schemas.openxmlformats.org/drawingml/2006/chart" r:id="rId1"/>
+          </a:graphicData>
+        </a:graphic>
+      </p:graphicFrame>
+      <p:sp>
+        <p:nvSpPr>
+          <p:cNvPr id="7" name="Shape 4"/>
+          <p:cNvSpPr/>
+          <p:nvPr/>
+        </p:nvSpPr>
+        <p:spPr>
+          <a:xfrm>
+            <a:off x="7543800" y="1600200"/>
+            <a:ext cx="4069080" cy="2148840"/>
+          </a:xfrm>
+          <a:prstGeom prst="roundRect">
+            <a:avLst>
+              <a:gd name="adj" fmla="val 2553"/>
+            </a:avLst>
+          </a:prstGeom>
+          <a:solidFill>
+            <a:srgbClr val="1C2128"/>
+          </a:solidFill>
+          <a:ln w="12700">
+            <a:solidFill>
+              <a:srgbClr val="30363D"/>
+            </a:solidFill>
+            <a:prstDash val="solid"/>
+          </a:ln>
+        </p:spPr>
+      </p:sp>
+      <p:sp>
+        <p:nvSpPr>
+          <p:cNvPr id="8" name="Text 5"/>
+          <p:cNvSpPr/>
+          <p:nvPr/>
+        </p:nvSpPr>
+        <p:spPr>
+          <a:xfrm>
+            <a:off x="7744968" y="1728216"/>
+            <a:ext cx="3666744" cy="310896"/>
+          </a:xfrm>
+          <a:prstGeom prst="rect">
+            <a:avLst/>
+          </a:prstGeom>
+          <a:noFill/>
+          <a:ln/>
+        </p:spPr>
+        <p:txBody>
+          <a:bodyPr wrap="square" lIns="0" tIns="0" rIns="0" bIns="0" rtlCol="0" anchor="ctr"/>
+          <a:lstStyle/>
+          <a:p>
+            <a:pPr indent="0" marL="0">
+              <a:buNone/>
+            </a:pPr>
+            <a:r>
+              <a:rPr lang="en-US" sz="1400" b="1" dirty="0">
+                <a:solidFill>
+                  <a:srgbClr val="7EE787"/>
+                </a:solidFill>
+                <a:latin typeface="Calibri" pitchFamily="34" charset="0"/>
+                <a:ea typeface="Calibri" pitchFamily="34" charset="-122"/>
+                <a:cs typeface="Calibri" pitchFamily="34" charset="-120"/>
+              </a:rPr>
+              <a:t>가장 큰 비중: MLP</a:t>
+            </a:r>
+            <a:endParaRPr lang="en-US" sz="1400" dirty="0"/>
+          </a:p>
+        </p:txBody>
+      </p:sp>
+      <p:sp>
+        <p:nvSpPr>
+          <p:cNvPr id="9" name="Text 6"/>
+          <p:cNvSpPr/>
+          <p:nvPr/>
+        </p:nvSpPr>
+        <p:spPr>
+          <a:xfrm>
+            <a:off x="7763256" y="2075688"/>
+            <a:ext cx="3648456" cy="1545336"/>
+          </a:xfrm>
+          <a:prstGeom prst="rect">
+            <a:avLst/>
+          </a:prstGeom>
+          <a:noFill/>
+          <a:ln/>
+        </p:spPr>
+        <p:txBody>
+          <a:bodyPr wrap="square" lIns="0" tIns="0" rIns="0" bIns="0" rtlCol="0" anchor="t"/>
+          <a:lstStyle/>
+          <a:p>
+            <a:pPr marL="342900" indent="-342900">
+              <a:spcAft>
+                <a:spcPts val="400"/>
+              </a:spcAft>
+              <a:buSzPct val="100000"/>
+              <a:buChar char="•"/>
+            </a:pPr>
+            <a:r>
+              <a:rPr lang="en-US" sz="1250" dirty="0">
+                <a:solidFill>
+                  <a:srgbClr val="E6EDF3"/>
+                </a:solidFill>
+                <a:latin typeface="Calibri" pitchFamily="34" charset="0"/>
+                <a:ea typeface="Calibri" pitchFamily="34" charset="-122"/>
+                <a:cs typeface="Calibri" pitchFamily="34" charset="-120"/>
+              </a:rPr>
+              <a:t>mlp_fc1 (64×16) + mlp_fc2 (16×64)</a:t>
+            </a:r>
+            <a:endParaRPr lang="en-US" sz="1250" dirty="0"/>
+          </a:p>
+          <a:p>
+            <a:pPr marL="342900" indent="-342900">
+              <a:spcAft>
+                <a:spcPts val="400"/>
+              </a:spcAft>
+              <a:buSzPct val="100000"/>
+              <a:buChar char="•"/>
+            </a:pPr>
+            <a:r>
+              <a:rPr lang="en-US" sz="1250" dirty="0">
+                <a:solidFill>
+                  <a:srgbClr val="E6EDF3"/>
+                </a:solidFill>
+                <a:latin typeface="Calibri" pitchFamily="34" charset="0"/>
+                <a:ea typeface="Calibri" pitchFamily="34" charset="-122"/>
+                <a:cs typeface="Calibri" pitchFamily="34" charset="-120"/>
+              </a:rPr>
+              <a:t>= 2,048개 (전체의 약 50%)</a:t>
+            </a:r>
+            <a:endParaRPr lang="en-US" sz="1250" dirty="0"/>
+          </a:p>
+          <a:p>
+            <a:pPr marL="342900" indent="-342900">
+              <a:spcAft>
+                <a:spcPts val="400"/>
+              </a:spcAft>
+              <a:buSzPct val="100000"/>
+              <a:buChar char="•"/>
+            </a:pPr>
+            <a:r>
+              <a:rPr lang="en-US" sz="1250" dirty="0">
+                <a:solidFill>
+                  <a:srgbClr val="E6EDF3"/>
+                </a:solidFill>
+                <a:latin typeface="Calibri" pitchFamily="34" charset="0"/>
+                <a:ea typeface="Calibri" pitchFamily="34" charset="-122"/>
+                <a:cs typeface="Calibri" pitchFamily="34" charset="-120"/>
+              </a:rPr>
+              <a:t>확장→활성화→축소 구조라 파라미터가 큼</a:t>
+            </a:r>
+            <a:endParaRPr lang="en-US" sz="1250" dirty="0"/>
+          </a:p>
+        </p:txBody>
+      </p:sp>
+      <p:sp>
+        <p:nvSpPr>
+          <p:cNvPr id="10" name="Shape 7"/>
+          <p:cNvSpPr/>
+          <p:nvPr/>
+        </p:nvSpPr>
+        <p:spPr>
+          <a:xfrm>
+            <a:off x="7543800" y="3840480"/>
+            <a:ext cx="4069080" cy="2103120"/>
+          </a:xfrm>
+          <a:prstGeom prst="roundRect">
+            <a:avLst>
+              <a:gd name="adj" fmla="val 2609"/>
+            </a:avLst>
+          </a:prstGeom>
+          <a:solidFill>
+            <a:srgbClr val="1C2128"/>
+          </a:solidFill>
+          <a:ln w="12700">
+            <a:solidFill>
+              <a:srgbClr val="30363D"/>
+            </a:solidFill>
+            <a:prstDash val="solid"/>
+          </a:ln>
+        </p:spPr>
+      </p:sp>
+      <p:sp>
+        <p:nvSpPr>
+          <p:cNvPr id="11" name="Text 8"/>
+          <p:cNvSpPr/>
+          <p:nvPr/>
+        </p:nvSpPr>
+        <p:spPr>
+          <a:xfrm>
+            <a:off x="7744968" y="3968496"/>
+            <a:ext cx="3666744" cy="310896"/>
+          </a:xfrm>
+          <a:prstGeom prst="rect">
+            <a:avLst/>
+          </a:prstGeom>
+          <a:noFill/>
+          <a:ln/>
+        </p:spPr>
+        <p:txBody>
+          <a:bodyPr wrap="square" lIns="0" tIns="0" rIns="0" bIns="0" rtlCol="0" anchor="ctr"/>
+          <a:lstStyle/>
+          <a:p>
+            <a:pPr indent="0" marL="0">
+              <a:buNone/>
+            </a:pPr>
+            <a:r>
+              <a:rPr lang="en-US" sz="1400" b="1" dirty="0">
+                <a:solidFill>
+                  <a:srgbClr val="58A6FF"/>
+                </a:solidFill>
+                <a:latin typeface="Calibri" pitchFamily="34" charset="0"/>
+                <a:ea typeface="Calibri" pitchFamily="34" charset="-122"/>
+                <a:cs typeface="Calibri" pitchFamily="34" charset="-120"/>
+              </a:rPr>
+              <a:t>구성 요약</a:t>
+            </a:r>
+            <a:endParaRPr lang="en-US" sz="1400" dirty="0"/>
+          </a:p>
+        </p:txBody>
+      </p:sp>
+      <p:sp>
+        <p:nvSpPr>
+          <p:cNvPr id="12" name="Text 9"/>
+          <p:cNvSpPr/>
+          <p:nvPr/>
+        </p:nvSpPr>
+        <p:spPr>
+          <a:xfrm>
+            <a:off x="7763256" y="4315968"/>
+            <a:ext cx="3648456" cy="1499616"/>
+          </a:xfrm>
+          <a:prstGeom prst="rect">
+            <a:avLst/>
+          </a:prstGeom>
+          <a:noFill/>
+          <a:ln/>
+        </p:spPr>
+        <p:txBody>
+          <a:bodyPr wrap="square" lIns="0" tIns="0" rIns="0" bIns="0" rtlCol="0" anchor="t"/>
+          <a:lstStyle/>
+          <a:p>
+            <a:pPr marL="342900" indent="-342900">
+              <a:spcAft>
+                <a:spcPts val="400"/>
+              </a:spcAft>
+              <a:buSzPct val="100000"/>
+              <a:buChar char="•"/>
+            </a:pPr>
+            <a:r>
+              <a:rPr lang="en-US" sz="1250" dirty="0">
+                <a:solidFill>
+                  <a:srgbClr val="E6EDF3"/>
+                </a:solidFill>
+                <a:latin typeface="Calibri" pitchFamily="34" charset="0"/>
+                <a:ea typeface="Calibri" pitchFamily="34" charset="-122"/>
+                <a:cs typeface="Calibri" pitchFamily="34" charset="-120"/>
+              </a:rPr>
+              <a:t>임베딩 wte+wpe: 560개</a:t>
+            </a:r>
+            <a:endParaRPr lang="en-US" sz="1250" dirty="0"/>
+          </a:p>
+          <a:p>
+            <a:pPr marL="342900" indent="-342900">
+              <a:spcAft>
+                <a:spcPts val="400"/>
+              </a:spcAft>
+              <a:buSzPct val="100000"/>
+              <a:buChar char="•"/>
+            </a:pPr>
+            <a:r>
+              <a:rPr lang="en-US" sz="1250" dirty="0">
+                <a:solidFill>
+                  <a:srgbClr val="E6EDF3"/>
+                </a:solidFill>
+                <a:latin typeface="Calibri" pitchFamily="34" charset="0"/>
+                <a:ea typeface="Calibri" pitchFamily="34" charset="-122"/>
+                <a:cs typeface="Calibri" pitchFamily="34" charset="-120"/>
+              </a:rPr>
+              <a:t>어텐션 Q/K/V/O: 1,024개 (256×4)</a:t>
+            </a:r>
+            <a:endParaRPr lang="en-US" sz="1250" dirty="0"/>
+          </a:p>
+          <a:p>
+            <a:pPr marL="342900" indent="-342900">
+              <a:spcAft>
+                <a:spcPts val="400"/>
+              </a:spcAft>
+              <a:buSzPct val="100000"/>
+              <a:buChar char="•"/>
+            </a:pPr>
+            <a:r>
+              <a:rPr lang="en-US" sz="1250" dirty="0">
+                <a:solidFill>
+                  <a:srgbClr val="E6EDF3"/>
+                </a:solidFill>
+                <a:latin typeface="Calibri" pitchFamily="34" charset="0"/>
+                <a:ea typeface="Calibri" pitchFamily="34" charset="-122"/>
+                <a:cs typeface="Calibri" pitchFamily="34" charset="-120"/>
+              </a:rPr>
+              <a:t>MLP fc1+fc2: 2,048개</a:t>
+            </a:r>
+            <a:endParaRPr lang="en-US" sz="1250" dirty="0"/>
+          </a:p>
+          <a:p>
+            <a:pPr marL="342900" indent="-342900">
+              <a:spcAft>
+                <a:spcPts val="400"/>
+              </a:spcAft>
+              <a:buSzPct val="100000"/>
+              <a:buChar char="•"/>
+            </a:pPr>
+            <a:r>
+              <a:rPr lang="en-US" sz="1250" dirty="0">
+                <a:solidFill>
+                  <a:srgbClr val="E6EDF3"/>
+                </a:solidFill>
+                <a:latin typeface="Calibri" pitchFamily="34" charset="0"/>
+                <a:ea typeface="Calibri" pitchFamily="34" charset="-122"/>
+                <a:cs typeface="Calibri" pitchFamily="34" charset="-120"/>
+              </a:rPr>
+              <a:t>출력 lm_head: 432개  → 합계 4,064</a:t>
+            </a:r>
+            <a:endParaRPr lang="en-US" sz="1250" dirty="0"/>
+          </a:p>
+        </p:txBody>
+      </p:sp>
+    </p:spTree>
+  </p:cSld>
+  <p:clrMapOvr>
+    <a:masterClrMapping/>
+  </p:clrMapOvr>
+</p:sld>
+</file>
+
 <file path=ppt/slides/slide2.xml><?xml version="1.0" encoding="utf-8"?>
 <p:sld xmlns:a="http://schemas.openxmlformats.org/drawingml/2006/main" xmlns:r="http://schemas.openxmlformats.org/officeDocument/2006/relationships" xmlns:p="http://schemas.openxmlformats.org/presentationml/2006/main">
   <p:cSld name="Slide 2">

</xml_diff>